<commit_message>
dashboard: 2026-09-13 16:50 刷新
</commit_message>
<xml_diff>
--- a/media/figstudio/bzso_taxonomy/taxonomy_phase_control_editable.pptx
+++ b/media/figstudio/bzso_taxonomy/taxonomy_phase_control_editable.pptx
@@ -3533,9 +3533,9 @@
           <a:solidFill>
             <a:srgbClr val="FFFFFF"/>
           </a:solidFill>
-          <a:ln w="23812">
+          <a:ln w="31749">
             <a:solidFill>
-              <a:srgbClr val="4A5158"/>
+              <a:srgbClr val="38525E"/>
             </a:solidFill>
           </a:ln>
           <a:effectLst/>
@@ -3597,7 +3597,7 @@
               </a:spcAft>
               <a:defRPr sz="1999" b="1" i="0" lang="zh-CN" dirty="0">
                 <a:solidFill>
-                  <a:srgbClr val="1F2326"/>
+                  <a:srgbClr val="10171F"/>
                 </a:solidFill>
                 <a:latin typeface="DejaVu Sans"/>
                 <a:ea typeface="DejaVu Sans"/>
@@ -3607,7 +3607,7 @@
             <a:r>
               <a:rPr sz="1999" b="1" i="0" lang="zh-CN" dirty="0">
                 <a:solidFill>
-                  <a:srgbClr val="1F2326"/>
+                  <a:srgbClr val="10171F"/>
                 </a:solidFill>
                 <a:latin typeface="DejaVu Sans"/>
                 <a:ea typeface="DejaVu Sans"/>
@@ -3629,7 +3629,7 @@
               </a:spcAft>
               <a:defRPr sz="1999" b="1" i="0" lang="zh-CN" dirty="0">
                 <a:solidFill>
-                  <a:srgbClr val="1F2326"/>
+                  <a:srgbClr val="10171F"/>
                 </a:solidFill>
                 <a:latin typeface="Noto Sans CJK SC"/>
                 <a:ea typeface="Noto Sans CJK SC"/>
@@ -3639,7 +3639,7 @@
             <a:r>
               <a:rPr sz="1999" b="1" i="0" lang="zh-CN" dirty="0">
                 <a:solidFill>
-                  <a:srgbClr val="1F2326"/>
+                  <a:srgbClr val="10171F"/>
                 </a:solidFill>
                 <a:latin typeface="Noto Sans CJK SC"/>
                 <a:ea typeface="Noto Sans CJK SC"/>
@@ -3669,9 +3669,9 @@
           <a:solidFill>
             <a:srgbClr val="FFFFFF"/>
           </a:solidFill>
-          <a:ln w="19843">
+          <a:ln w="27781">
             <a:solidFill>
-              <a:srgbClr val="4A5158"/>
+              <a:srgbClr val="3F4A53"/>
             </a:solidFill>
           </a:ln>
           <a:effectLst/>
@@ -3733,7 +3733,7 @@
               </a:spcAft>
               <a:defRPr sz="2478" b="1" i="0" lang="zh-CN" dirty="0">
                 <a:solidFill>
-                  <a:srgbClr val="1F2326"/>
+                  <a:srgbClr val="10171F"/>
                 </a:solidFill>
                 <a:latin typeface="Noto Sans CJK SC"/>
                 <a:ea typeface="Noto Sans CJK SC"/>
@@ -3743,7 +3743,7 @@
             <a:r>
               <a:rPr sz="2478" b="1" i="0" lang="zh-CN" dirty="0">
                 <a:solidFill>
-                  <a:srgbClr val="1F2326"/>
+                  <a:srgbClr val="10171F"/>
                 </a:solidFill>
                 <a:latin typeface="Noto Sans CJK SC"/>
                 <a:ea typeface="Noto Sans CJK SC"/>
@@ -3789,7 +3789,7 @@
               </a:spcAft>
               <a:defRPr sz="1687" b="0" i="0" lang="zh-CN" dirty="0">
                 <a:solidFill>
-                  <a:srgbClr val="3A4046"/>
+                  <a:srgbClr val="2B333A"/>
                 </a:solidFill>
                 <a:latin typeface="Noto Sans CJK SC"/>
                 <a:ea typeface="Noto Sans CJK SC"/>
@@ -3799,7 +3799,7 @@
             <a:r>
               <a:rPr sz="1687" b="0" i="0" lang="zh-CN" dirty="0">
                 <a:solidFill>
-                  <a:srgbClr val="3A4046"/>
+                  <a:srgbClr val="2B333A"/>
                 </a:solidFill>
                 <a:latin typeface="Noto Sans CJK SC"/>
                 <a:ea typeface="Noto Sans CJK SC"/>
@@ -3810,7 +3810,7 @@
             <a:r>
               <a:rPr sz="1687" b="0" i="0" lang="zh-CN" dirty="0">
                 <a:solidFill>
-                  <a:srgbClr val="3A4046"/>
+                  <a:srgbClr val="2B333A"/>
                 </a:solidFill>
                 <a:latin typeface="DejaVu Sans"/>
                 <a:ea typeface="DejaVu Sans"/>
@@ -3821,7 +3821,7 @@
             <a:r>
               <a:rPr sz="1687" b="0" i="0" lang="zh-CN" dirty="0">
                 <a:solidFill>
-                  <a:srgbClr val="3A4046"/>
+                  <a:srgbClr val="2B333A"/>
                 </a:solidFill>
                 <a:latin typeface="Noto Sans CJK SC"/>
                 <a:ea typeface="Noto Sans CJK SC"/>
@@ -3846,9 +3846,9 @@
           <a:prstGeom prst="line">
             <a:avLst/>
           </a:prstGeom>
-          <a:ln w="23812">
+          <a:ln w="31749">
             <a:solidFill>
-              <a:srgbClr val="1F6F78"/>
+              <a:srgbClr val="1B717D"/>
             </a:solidFill>
           </a:ln>
           <a:effectLst/>
@@ -3877,7 +3877,7 @@
         <p:spPr>
           <a:xfrm>
             <a:off x="4246562" y="1714500"/>
-            <a:ext cx="222734" cy="222734"/>
+            <a:ext cx="225536" cy="225536"/>
           </a:xfrm>
           <a:custGeom>
             <a:avLst/>
@@ -3886,34 +3886,34 @@
             <a:cxnLst/>
             <a:rect l="l" t="t" r="r" b="b"/>
             <a:pathLst>
-              <a:path w="28061" h="28061">
+              <a:path w="28414" h="28414">
                 <a:moveTo>
-                  <a:pt x="25939" y="28061"/>
+                  <a:pt x="25586" y="28414"/>
                 </a:moveTo>
                 <a:lnTo>
-                  <a:pt x="8839" y="10960"/>
+                  <a:pt x="9899" y="12728"/>
                 </a:lnTo>
                 <a:lnTo>
-                  <a:pt x="5657" y="14142"/>
+                  <a:pt x="6364" y="16263"/>
                 </a:lnTo>
                 <a:lnTo>
                   <a:pt x="0" y="0"/>
                 </a:lnTo>
                 <a:lnTo>
-                  <a:pt x="14142" y="5657"/>
+                  <a:pt x="16263" y="6364"/>
                 </a:lnTo>
                 <a:lnTo>
-                  <a:pt x="10960" y="8839"/>
+                  <a:pt x="12728" y="9899"/>
                 </a:lnTo>
                 <a:lnTo>
-                  <a:pt x="28061" y="25939"/>
+                  <a:pt x="28414" y="25586"/>
                 </a:lnTo>
                 <a:close/>
               </a:path>
             </a:pathLst>
           </a:custGeom>
           <a:solidFill>
-            <a:srgbClr val="1F6F78"/>
+            <a:srgbClr val="1B717D"/>
           </a:solidFill>
           <a:ln>
             <a:noFill/>
@@ -3959,11 +3959,11 @@
             </a:avLst>
           </a:prstGeom>
           <a:solidFill>
-            <a:srgbClr val="FFFFFF"/>
+            <a:srgbClr val="E9EDED"/>
           </a:solidFill>
-          <a:ln w="15874">
+          <a:ln w="19843">
             <a:solidFill>
-              <a:srgbClr val="1F6F78"/>
+              <a:srgbClr val="1B717D"/>
             </a:solidFill>
           </a:ln>
           <a:effectLst/>
@@ -4025,7 +4025,7 @@
               </a:spcAft>
               <a:defRPr sz="1499" b="1" i="0" lang="zh-CN" dirty="0">
                 <a:solidFill>
-                  <a:srgbClr val="1F6F78"/>
+                  <a:srgbClr val="1B717D"/>
                 </a:solidFill>
                 <a:latin typeface="Noto Sans CJK SC"/>
                 <a:ea typeface="Noto Sans CJK SC"/>
@@ -4035,7 +4035,7 @@
             <a:r>
               <a:rPr sz="1499" b="1" i="0" lang="zh-CN" dirty="0">
                 <a:solidFill>
-                  <a:srgbClr val="1F6F78"/>
+                  <a:srgbClr val="1B717D"/>
                 </a:solidFill>
                 <a:latin typeface="Noto Sans CJK SC"/>
                 <a:ea typeface="Noto Sans CJK SC"/>
@@ -4065,9 +4065,9 @@
           <a:solidFill>
             <a:srgbClr val="FFFFFF"/>
           </a:solidFill>
-          <a:ln w="19843">
+          <a:ln w="27781">
             <a:solidFill>
-              <a:srgbClr val="4A5158"/>
+              <a:srgbClr val="3F4A53"/>
             </a:solidFill>
           </a:ln>
           <a:effectLst/>
@@ -4129,7 +4129,7 @@
               </a:spcAft>
               <a:defRPr sz="2478" b="1" i="0" lang="zh-CN" dirty="0">
                 <a:solidFill>
-                  <a:srgbClr val="1F2326"/>
+                  <a:srgbClr val="10171F"/>
                 </a:solidFill>
                 <a:latin typeface="Noto Sans CJK SC"/>
                 <a:ea typeface="Noto Sans CJK SC"/>
@@ -4139,7 +4139,7 @@
             <a:r>
               <a:rPr sz="2478" b="1" i="0" lang="zh-CN" dirty="0">
                 <a:solidFill>
-                  <a:srgbClr val="1F2326"/>
+                  <a:srgbClr val="10171F"/>
                 </a:solidFill>
                 <a:latin typeface="Noto Sans CJK SC"/>
                 <a:ea typeface="Noto Sans CJK SC"/>
@@ -4185,7 +4185,7 @@
               </a:spcAft>
               <a:defRPr sz="1687" b="0" i="0" lang="zh-CN" dirty="0">
                 <a:solidFill>
-                  <a:srgbClr val="3A4046"/>
+                  <a:srgbClr val="2B333A"/>
                 </a:solidFill>
                 <a:latin typeface="Noto Sans CJK SC"/>
                 <a:ea typeface="Noto Sans CJK SC"/>
@@ -4195,7 +4195,7 @@
             <a:r>
               <a:rPr sz="1687" b="0" i="0" lang="zh-CN" dirty="0">
                 <a:solidFill>
-                  <a:srgbClr val="3A4046"/>
+                  <a:srgbClr val="2B333A"/>
                 </a:solidFill>
                 <a:latin typeface="Noto Sans CJK SC"/>
                 <a:ea typeface="Noto Sans CJK SC"/>
@@ -4206,7 +4206,7 @@
             <a:r>
               <a:rPr sz="1687" b="0" i="0" lang="zh-CN" dirty="0">
                 <a:solidFill>
-                  <a:srgbClr val="3A4046"/>
+                  <a:srgbClr val="2B333A"/>
                 </a:solidFill>
                 <a:latin typeface="DejaVu Sans"/>
                 <a:ea typeface="DejaVu Sans"/>
@@ -4217,7 +4217,7 @@
             <a:r>
               <a:rPr sz="1687" b="0" i="0" lang="zh-CN" dirty="0">
                 <a:solidFill>
-                  <a:srgbClr val="3A4046"/>
+                  <a:srgbClr val="2B333A"/>
                 </a:solidFill>
                 <a:latin typeface="Noto Sans CJK SC"/>
                 <a:ea typeface="Noto Sans CJK SC"/>
@@ -4228,7 +4228,7 @@
             <a:r>
               <a:rPr sz="1687" b="0" i="0" lang="zh-CN" dirty="0">
                 <a:solidFill>
-                  <a:srgbClr val="3A4046"/>
+                  <a:srgbClr val="2B333A"/>
                 </a:solidFill>
                 <a:latin typeface="DejaVu Sans"/>
                 <a:ea typeface="DejaVu Sans"/>
@@ -4239,7 +4239,7 @@
             <a:r>
               <a:rPr sz="1687" b="0" i="0" lang="zh-CN" dirty="0">
                 <a:solidFill>
-                  <a:srgbClr val="3A4046"/>
+                  <a:srgbClr val="2B333A"/>
                 </a:solidFill>
                 <a:latin typeface="Noto Sans CJK SC"/>
                 <a:ea typeface="Noto Sans CJK SC"/>
@@ -4264,9 +4264,9 @@
           <a:prstGeom prst="line">
             <a:avLst/>
           </a:prstGeom>
-          <a:ln w="23812">
+          <a:ln w="31749">
             <a:solidFill>
-              <a:srgbClr val="1F6F78"/>
+              <a:srgbClr val="1B717D"/>
             </a:solidFill>
           </a:ln>
           <a:effectLst/>
@@ -4294,8 +4294,8 @@
         </p:nvSpPr>
         <p:spPr>
           <a:xfrm>
-            <a:off x="7714766" y="1714500"/>
-            <a:ext cx="222734" cy="222734"/>
+            <a:off x="7711964" y="1714500"/>
+            <a:ext cx="225536" cy="225536"/>
           </a:xfrm>
           <a:custGeom>
             <a:avLst/>
@@ -4304,34 +4304,34 @@
             <a:cxnLst/>
             <a:rect l="l" t="t" r="r" b="b"/>
             <a:pathLst>
-              <a:path w="28061" h="28061">
+              <a:path w="28414" h="28414">
                 <a:moveTo>
-                  <a:pt x="0" y="25939"/>
+                  <a:pt x="0" y="25586"/>
                 </a:moveTo>
                 <a:lnTo>
-                  <a:pt x="17101" y="8839"/>
+                  <a:pt x="15686" y="9899"/>
                 </a:lnTo>
                 <a:lnTo>
-                  <a:pt x="13919" y="5657"/>
+                  <a:pt x="12151" y="6364"/>
                 </a:lnTo>
                 <a:lnTo>
-                  <a:pt x="28061" y="0"/>
+                  <a:pt x="28414" y="0"/>
                 </a:lnTo>
                 <a:lnTo>
-                  <a:pt x="22404" y="14142"/>
+                  <a:pt x="22050" y="16263"/>
                 </a:lnTo>
                 <a:lnTo>
-                  <a:pt x="19222" y="10960"/>
+                  <a:pt x="18515" y="12728"/>
                 </a:lnTo>
                 <a:lnTo>
-                  <a:pt x="2122" y="28061"/>
+                  <a:pt x="2828" y="28414"/>
                 </a:lnTo>
                 <a:close/>
               </a:path>
             </a:pathLst>
           </a:custGeom>
           <a:solidFill>
-            <a:srgbClr val="1F6F78"/>
+            <a:srgbClr val="1B717D"/>
           </a:solidFill>
           <a:ln>
             <a:noFill/>
@@ -4377,11 +4377,11 @@
             </a:avLst>
           </a:prstGeom>
           <a:solidFill>
-            <a:srgbClr val="FFFFFF"/>
+            <a:srgbClr val="E9EDED"/>
           </a:solidFill>
-          <a:ln w="15874">
+          <a:ln w="19843">
             <a:solidFill>
-              <a:srgbClr val="1F6F78"/>
+              <a:srgbClr val="1B717D"/>
             </a:solidFill>
           </a:ln>
           <a:effectLst/>
@@ -4443,7 +4443,7 @@
               </a:spcAft>
               <a:defRPr sz="1499" b="1" i="0" lang="zh-CN" dirty="0">
                 <a:solidFill>
-                  <a:srgbClr val="1F6F78"/>
+                  <a:srgbClr val="1B717D"/>
                 </a:solidFill>
                 <a:latin typeface="Noto Sans CJK SC"/>
                 <a:ea typeface="Noto Sans CJK SC"/>
@@ -4453,7 +4453,7 @@
             <a:r>
               <a:rPr sz="1499" b="1" i="0" lang="zh-CN" dirty="0">
                 <a:solidFill>
-                  <a:srgbClr val="1F6F78"/>
+                  <a:srgbClr val="1B717D"/>
                 </a:solidFill>
                 <a:latin typeface="Noto Sans CJK SC"/>
                 <a:ea typeface="Noto Sans CJK SC"/>
@@ -4483,9 +4483,9 @@
           <a:solidFill>
             <a:srgbClr val="FFFFFF"/>
           </a:solidFill>
-          <a:ln w="19843">
+          <a:ln w="27781">
             <a:solidFill>
-              <a:srgbClr val="4A5158"/>
+              <a:srgbClr val="3F4A53"/>
             </a:solidFill>
           </a:ln>
           <a:effectLst/>
@@ -4547,7 +4547,7 @@
               </a:spcAft>
               <a:defRPr sz="2478" b="1" i="0" lang="zh-CN" dirty="0">
                 <a:solidFill>
-                  <a:srgbClr val="1F2326"/>
+                  <a:srgbClr val="10171F"/>
                 </a:solidFill>
                 <a:latin typeface="Noto Sans CJK SC"/>
                 <a:ea typeface="Noto Sans CJK SC"/>
@@ -4557,7 +4557,7 @@
             <a:r>
               <a:rPr sz="2478" b="1" i="0" lang="zh-CN" dirty="0">
                 <a:solidFill>
-                  <a:srgbClr val="1F2326"/>
+                  <a:srgbClr val="10171F"/>
                 </a:solidFill>
                 <a:latin typeface="Noto Sans CJK SC"/>
                 <a:ea typeface="Noto Sans CJK SC"/>
@@ -4603,7 +4603,7 @@
               </a:spcAft>
               <a:defRPr sz="1687" b="0" i="0" lang="zh-CN" dirty="0">
                 <a:solidFill>
-                  <a:srgbClr val="3A4046"/>
+                  <a:srgbClr val="2B333A"/>
                 </a:solidFill>
                 <a:latin typeface="DejaVu Sans"/>
                 <a:ea typeface="DejaVu Sans"/>
@@ -4613,7 +4613,7 @@
             <a:r>
               <a:rPr sz="1687" b="0" i="0" lang="zh-CN" dirty="0">
                 <a:solidFill>
-                  <a:srgbClr val="3A4046"/>
+                  <a:srgbClr val="2B333A"/>
                 </a:solidFill>
                 <a:latin typeface="DejaVu Sans"/>
                 <a:ea typeface="DejaVu Sans"/>
@@ -4624,7 +4624,7 @@
             <a:r>
               <a:rPr sz="1687" b="0" i="0" lang="zh-CN" dirty="0">
                 <a:solidFill>
-                  <a:srgbClr val="3A4046"/>
+                  <a:srgbClr val="2B333A"/>
                 </a:solidFill>
                 <a:latin typeface="Noto Sans CJK SC"/>
                 <a:ea typeface="Noto Sans CJK SC"/>
@@ -4649,9 +4649,9 @@
           <a:prstGeom prst="line">
             <a:avLst/>
           </a:prstGeom>
-          <a:ln w="23812">
+          <a:ln w="31749">
             <a:solidFill>
-              <a:srgbClr val="1F6F78"/>
+              <a:srgbClr val="1B717D"/>
             </a:solidFill>
           </a:ln>
           <a:effectLst/>
@@ -4679,8 +4679,8 @@
         </p:nvSpPr>
         <p:spPr>
           <a:xfrm>
-            <a:off x="2928937" y="3516312"/>
-            <a:ext cx="595312" cy="95250"/>
+            <a:off x="2928937" y="3508375"/>
+            <a:ext cx="595312" cy="111125"/>
           </a:xfrm>
           <a:custGeom>
             <a:avLst/>
@@ -4689,34 +4689,34 @@
             <a:cxnLst/>
             <a:rect l="l" t="t" r="r" b="b"/>
             <a:pathLst>
-              <a:path w="75000" h="12000">
+              <a:path w="75000" h="14000">
                 <a:moveTo>
-                  <a:pt x="75000" y="7500"/>
+                  <a:pt x="75000" y="9000"/>
                 </a:moveTo>
                 <a:lnTo>
-                  <a:pt x="14000" y="7500"/>
+                  <a:pt x="16000" y="9000"/>
                 </a:lnTo>
                 <a:lnTo>
-                  <a:pt x="14000" y="12000"/>
+                  <a:pt x="16000" y="14000"/>
                 </a:lnTo>
                 <a:lnTo>
-                  <a:pt x="0" y="6000"/>
+                  <a:pt x="0" y="7000"/>
                 </a:lnTo>
                 <a:lnTo>
-                  <a:pt x="14000" y="0"/>
+                  <a:pt x="16000" y="0"/>
                 </a:lnTo>
                 <a:lnTo>
-                  <a:pt x="14000" y="4500"/>
+                  <a:pt x="16000" y="5000"/>
                 </a:lnTo>
                 <a:lnTo>
-                  <a:pt x="75000" y="4500"/>
+                  <a:pt x="75000" y="5000"/>
                 </a:lnTo>
                 <a:close/>
               </a:path>
             </a:pathLst>
           </a:custGeom>
           <a:solidFill>
-            <a:srgbClr val="1F6F78"/>
+            <a:srgbClr val="1B717D"/>
           </a:solidFill>
           <a:ln>
             <a:noFill/>
@@ -4762,11 +4762,11 @@
             </a:avLst>
           </a:prstGeom>
           <a:solidFill>
-            <a:srgbClr val="FFFFFF"/>
+            <a:srgbClr val="E9EDED"/>
           </a:solidFill>
-          <a:ln w="15874">
+          <a:ln w="19843">
             <a:solidFill>
-              <a:srgbClr val="1F6F78"/>
+              <a:srgbClr val="1B717D"/>
             </a:solidFill>
           </a:ln>
           <a:effectLst/>
@@ -4828,7 +4828,7 @@
               </a:spcAft>
               <a:defRPr sz="1499" b="1" i="0" lang="zh-CN" dirty="0">
                 <a:solidFill>
-                  <a:srgbClr val="1F6F78"/>
+                  <a:srgbClr val="1B717D"/>
                 </a:solidFill>
                 <a:latin typeface="Noto Sans CJK SC"/>
                 <a:ea typeface="Noto Sans CJK SC"/>
@@ -4838,7 +4838,7 @@
             <a:r>
               <a:rPr sz="1499" b="1" i="0" lang="zh-CN" dirty="0">
                 <a:solidFill>
-                  <a:srgbClr val="1F6F78"/>
+                  <a:srgbClr val="1B717D"/>
                 </a:solidFill>
                 <a:latin typeface="Noto Sans CJK SC"/>
                 <a:ea typeface="Noto Sans CJK SC"/>
@@ -4868,9 +4868,9 @@
           <a:solidFill>
             <a:srgbClr val="FFFFFF"/>
           </a:solidFill>
-          <a:ln w="19843">
+          <a:ln w="27781">
             <a:solidFill>
-              <a:srgbClr val="4A5158"/>
+              <a:srgbClr val="3F4A53"/>
             </a:solidFill>
           </a:ln>
           <a:effectLst/>
@@ -4932,7 +4932,7 @@
               </a:spcAft>
               <a:defRPr sz="2478" b="1" i="0" lang="zh-CN" dirty="0">
                 <a:solidFill>
-                  <a:srgbClr val="1F2326"/>
+                  <a:srgbClr val="10171F"/>
                 </a:solidFill>
                 <a:latin typeface="Noto Sans CJK SC"/>
                 <a:ea typeface="Noto Sans CJK SC"/>
@@ -4942,7 +4942,7 @@
             <a:r>
               <a:rPr sz="2478" b="1" i="0" lang="zh-CN" dirty="0">
                 <a:solidFill>
-                  <a:srgbClr val="1F2326"/>
+                  <a:srgbClr val="10171F"/>
                 </a:solidFill>
                 <a:latin typeface="Noto Sans CJK SC"/>
                 <a:ea typeface="Noto Sans CJK SC"/>
@@ -4988,7 +4988,7 @@
               </a:spcAft>
               <a:defRPr sz="1687" b="0" i="0" lang="zh-CN" dirty="0">
                 <a:solidFill>
-                  <a:srgbClr val="3A4046"/>
+                  <a:srgbClr val="2B333A"/>
                 </a:solidFill>
                 <a:latin typeface="Noto Sans CJK SC"/>
                 <a:ea typeface="Noto Sans CJK SC"/>
@@ -4998,7 +4998,7 @@
             <a:r>
               <a:rPr sz="1687" b="0" i="0" lang="zh-CN" dirty="0">
                 <a:solidFill>
-                  <a:srgbClr val="3A4046"/>
+                  <a:srgbClr val="2B333A"/>
                 </a:solidFill>
                 <a:latin typeface="Noto Sans CJK SC"/>
                 <a:ea typeface="Noto Sans CJK SC"/>
@@ -5009,7 +5009,7 @@
             <a:r>
               <a:rPr sz="1687" b="0" i="0" lang="zh-CN" dirty="0">
                 <a:solidFill>
-                  <a:srgbClr val="3A4046"/>
+                  <a:srgbClr val="2B333A"/>
                 </a:solidFill>
                 <a:latin typeface="DejaVu Sans"/>
                 <a:ea typeface="DejaVu Sans"/>
@@ -5020,7 +5020,7 @@
             <a:r>
               <a:rPr sz="1687" b="0" i="0" lang="zh-CN" dirty="0">
                 <a:solidFill>
-                  <a:srgbClr val="3A4046"/>
+                  <a:srgbClr val="2B333A"/>
                 </a:solidFill>
                 <a:latin typeface="Noto Sans CJK SC"/>
                 <a:ea typeface="Noto Sans CJK SC"/>
@@ -5031,7 +5031,7 @@
             <a:r>
               <a:rPr sz="1687" b="0" i="0" lang="zh-CN" dirty="0">
                 <a:solidFill>
-                  <a:srgbClr val="3A4046"/>
+                  <a:srgbClr val="2B333A"/>
                 </a:solidFill>
                 <a:latin typeface="DejaVu Sans"/>
                 <a:ea typeface="DejaVu Sans"/>
@@ -5042,7 +5042,7 @@
             <a:r>
               <a:rPr sz="1687" b="0" i="0" lang="zh-CN" dirty="0">
                 <a:solidFill>
-                  <a:srgbClr val="3A4046"/>
+                  <a:srgbClr val="2B333A"/>
                 </a:solidFill>
                 <a:latin typeface="Noto Sans CJK SC"/>
                 <a:ea typeface="Noto Sans CJK SC"/>
@@ -5067,9 +5067,9 @@
           <a:prstGeom prst="line">
             <a:avLst/>
           </a:prstGeom>
-          <a:ln w="23812">
+          <a:ln w="31749">
             <a:solidFill>
-              <a:srgbClr val="1F6F78"/>
+              <a:srgbClr val="1B717D"/>
             </a:solidFill>
           </a:ln>
           <a:effectLst/>
@@ -5097,8 +5097,8 @@
         </p:nvSpPr>
         <p:spPr>
           <a:xfrm>
-            <a:off x="8667750" y="3516312"/>
-            <a:ext cx="587375" cy="95250"/>
+            <a:off x="8667750" y="3508375"/>
+            <a:ext cx="587375" cy="111125"/>
           </a:xfrm>
           <a:custGeom>
             <a:avLst/>
@@ -5107,34 +5107,34 @@
             <a:cxnLst/>
             <a:rect l="l" t="t" r="r" b="b"/>
             <a:pathLst>
-              <a:path w="74000" h="12000">
+              <a:path w="74000" h="14000">
                 <a:moveTo>
-                  <a:pt x="0" y="4500"/>
+                  <a:pt x="0" y="5000"/>
                 </a:moveTo>
                 <a:lnTo>
-                  <a:pt x="60000" y="4500"/>
+                  <a:pt x="58000" y="5000"/>
                 </a:lnTo>
                 <a:lnTo>
-                  <a:pt x="60000" y="0"/>
+                  <a:pt x="58000" y="0"/>
                 </a:lnTo>
                 <a:lnTo>
-                  <a:pt x="74000" y="6000"/>
+                  <a:pt x="74000" y="7000"/>
                 </a:lnTo>
                 <a:lnTo>
-                  <a:pt x="60000" y="12000"/>
+                  <a:pt x="58000" y="14000"/>
                 </a:lnTo>
                 <a:lnTo>
-                  <a:pt x="60000" y="7500"/>
+                  <a:pt x="58000" y="9000"/>
                 </a:lnTo>
                 <a:lnTo>
-                  <a:pt x="0" y="7500"/>
+                  <a:pt x="0" y="9000"/>
                 </a:lnTo>
                 <a:close/>
               </a:path>
             </a:pathLst>
           </a:custGeom>
           <a:solidFill>
-            <a:srgbClr val="1F6F78"/>
+            <a:srgbClr val="1B717D"/>
           </a:solidFill>
           <a:ln>
             <a:noFill/>
@@ -5180,11 +5180,11 @@
             </a:avLst>
           </a:prstGeom>
           <a:solidFill>
-            <a:srgbClr val="FFFFFF"/>
+            <a:srgbClr val="E9EDED"/>
           </a:solidFill>
-          <a:ln w="15874">
+          <a:ln w="19843">
             <a:solidFill>
-              <a:srgbClr val="1F6F78"/>
+              <a:srgbClr val="1B717D"/>
             </a:solidFill>
           </a:ln>
           <a:effectLst/>
@@ -5246,7 +5246,7 @@
               </a:spcAft>
               <a:defRPr sz="1499" b="1" i="0" lang="zh-CN" dirty="0">
                 <a:solidFill>
-                  <a:srgbClr val="1F6F78"/>
+                  <a:srgbClr val="1B717D"/>
                 </a:solidFill>
                 <a:latin typeface="Noto Sans CJK SC"/>
                 <a:ea typeface="Noto Sans CJK SC"/>
@@ -5256,7 +5256,7 @@
             <a:r>
               <a:rPr sz="1499" b="1" i="0" lang="zh-CN" dirty="0">
                 <a:solidFill>
-                  <a:srgbClr val="1F6F78"/>
+                  <a:srgbClr val="1B717D"/>
                 </a:solidFill>
                 <a:latin typeface="Noto Sans CJK SC"/>
                 <a:ea typeface="Noto Sans CJK SC"/>
@@ -5286,9 +5286,9 @@
           <a:solidFill>
             <a:srgbClr val="FFFFFF"/>
           </a:solidFill>
-          <a:ln w="19843">
+          <a:ln w="27781">
             <a:solidFill>
-              <a:srgbClr val="4A5158"/>
+              <a:srgbClr val="3F4A53"/>
             </a:solidFill>
           </a:ln>
           <a:effectLst/>
@@ -5350,7 +5350,7 @@
               </a:spcAft>
               <a:defRPr sz="2478" b="1" i="0" lang="zh-CN" dirty="0">
                 <a:solidFill>
-                  <a:srgbClr val="1F2326"/>
+                  <a:srgbClr val="10171F"/>
                 </a:solidFill>
                 <a:latin typeface="Noto Sans CJK SC"/>
                 <a:ea typeface="Noto Sans CJK SC"/>
@@ -5360,7 +5360,7 @@
             <a:r>
               <a:rPr sz="2478" b="1" i="0" lang="zh-CN" dirty="0">
                 <a:solidFill>
-                  <a:srgbClr val="1F2326"/>
+                  <a:srgbClr val="10171F"/>
                 </a:solidFill>
                 <a:latin typeface="Noto Sans CJK SC"/>
                 <a:ea typeface="Noto Sans CJK SC"/>
@@ -5406,7 +5406,7 @@
               </a:spcAft>
               <a:defRPr sz="1687" b="0" i="0" lang="zh-CN" dirty="0">
                 <a:solidFill>
-                  <a:srgbClr val="3A4046"/>
+                  <a:srgbClr val="2B333A"/>
                 </a:solidFill>
                 <a:latin typeface="DejaVu Sans"/>
                 <a:ea typeface="DejaVu Sans"/>
@@ -5416,7 +5416,7 @@
             <a:r>
               <a:rPr sz="1687" b="0" i="0" lang="zh-CN" dirty="0">
                 <a:solidFill>
-                  <a:srgbClr val="3A4046"/>
+                  <a:srgbClr val="2B333A"/>
                 </a:solidFill>
                 <a:latin typeface="DejaVu Sans"/>
                 <a:ea typeface="DejaVu Sans"/>
@@ -5427,7 +5427,7 @@
             <a:r>
               <a:rPr sz="1687" b="0" i="0" lang="zh-CN" dirty="0">
                 <a:solidFill>
-                  <a:srgbClr val="3A4046"/>
+                  <a:srgbClr val="2B333A"/>
                 </a:solidFill>
                 <a:latin typeface="Noto Sans CJK SC"/>
                 <a:ea typeface="Noto Sans CJK SC"/>
@@ -5452,9 +5452,9 @@
           <a:prstGeom prst="line">
             <a:avLst/>
           </a:prstGeom>
-          <a:ln w="23812">
+          <a:ln w="31749">
             <a:solidFill>
-              <a:srgbClr val="1F6F78"/>
+              <a:srgbClr val="1B717D"/>
             </a:solidFill>
           </a:ln>
           <a:effectLst/>
@@ -5482,8 +5482,8 @@
         </p:nvSpPr>
         <p:spPr>
           <a:xfrm>
-            <a:off x="3968750" y="5174210"/>
-            <a:ext cx="317389" cy="278852"/>
+            <a:off x="3968750" y="5171218"/>
+            <a:ext cx="319992" cy="281845"/>
           </a:xfrm>
           <a:custGeom>
             <a:avLst/>
@@ -5492,34 +5492,34 @@
             <a:cxnLst/>
             <a:rect l="l" t="t" r="r" b="b"/>
             <a:pathLst>
-              <a:path w="39986" h="35131">
+              <a:path w="40314" h="35508">
                 <a:moveTo>
-                  <a:pt x="39986" y="2262"/>
+                  <a:pt x="40314" y="3016"/>
                 </a:moveTo>
                 <a:lnTo>
-                  <a:pt x="11539" y="27062"/>
+                  <a:pt x="13375" y="26501"/>
                 </a:lnTo>
                 <a:lnTo>
-                  <a:pt x="14496" y="30454"/>
+                  <a:pt x="16660" y="30270"/>
                 </a:lnTo>
                 <a:lnTo>
-                  <a:pt x="0" y="35131"/>
+                  <a:pt x="0" y="35508"/>
                 </a:lnTo>
                 <a:lnTo>
-                  <a:pt x="6610" y="21408"/>
+                  <a:pt x="7460" y="19717"/>
                 </a:lnTo>
                 <a:lnTo>
-                  <a:pt x="9567" y="24800"/>
+                  <a:pt x="10746" y="23486"/>
                 </a:lnTo>
                 <a:lnTo>
-                  <a:pt x="38014" y="0"/>
+                  <a:pt x="37686" y="0"/>
                 </a:lnTo>
                 <a:close/>
               </a:path>
             </a:pathLst>
           </a:custGeom>
           <a:solidFill>
-            <a:srgbClr val="1F6F78"/>
+            <a:srgbClr val="1B717D"/>
           </a:solidFill>
           <a:ln>
             <a:noFill/>
@@ -5565,11 +5565,11 @@
             </a:avLst>
           </a:prstGeom>
           <a:solidFill>
-            <a:srgbClr val="FFFFFF"/>
+            <a:srgbClr val="E9EDED"/>
           </a:solidFill>
-          <a:ln w="15874">
+          <a:ln w="19843">
             <a:solidFill>
-              <a:srgbClr val="1F6F78"/>
+              <a:srgbClr val="1B717D"/>
             </a:solidFill>
           </a:ln>
           <a:effectLst/>
@@ -5631,7 +5631,7 @@
               </a:spcAft>
               <a:defRPr sz="1499" b="1" i="0" lang="zh-CN" dirty="0">
                 <a:solidFill>
-                  <a:srgbClr val="1F6F78"/>
+                  <a:srgbClr val="1B717D"/>
                 </a:solidFill>
                 <a:latin typeface="Noto Sans CJK SC"/>
                 <a:ea typeface="Noto Sans CJK SC"/>
@@ -5641,7 +5641,7 @@
             <a:r>
               <a:rPr sz="1499" b="1" i="0" lang="zh-CN" dirty="0">
                 <a:solidFill>
-                  <a:srgbClr val="1F6F78"/>
+                  <a:srgbClr val="1B717D"/>
                 </a:solidFill>
                 <a:latin typeface="Noto Sans CJK SC"/>
                 <a:ea typeface="Noto Sans CJK SC"/>
@@ -5671,9 +5671,9 @@
           <a:solidFill>
             <a:srgbClr val="FFFFFF"/>
           </a:solidFill>
-          <a:ln w="19843">
+          <a:ln w="27781">
             <a:solidFill>
-              <a:srgbClr val="4A5158"/>
+              <a:srgbClr val="3F4A53"/>
             </a:solidFill>
           </a:ln>
           <a:effectLst/>
@@ -5735,7 +5735,7 @@
               </a:spcAft>
               <a:defRPr sz="2478" b="1" i="0" lang="zh-CN" dirty="0">
                 <a:solidFill>
-                  <a:srgbClr val="1F2326"/>
+                  <a:srgbClr val="10171F"/>
                 </a:solidFill>
                 <a:latin typeface="Noto Sans CJK SC"/>
                 <a:ea typeface="Noto Sans CJK SC"/>
@@ -5745,7 +5745,7 @@
             <a:r>
               <a:rPr sz="2478" b="1" i="0" lang="zh-CN" dirty="0">
                 <a:solidFill>
-                  <a:srgbClr val="1F2326"/>
+                  <a:srgbClr val="10171F"/>
                 </a:solidFill>
                 <a:latin typeface="Noto Sans CJK SC"/>
                 <a:ea typeface="Noto Sans CJK SC"/>
@@ -5791,7 +5791,7 @@
               </a:spcAft>
               <a:defRPr sz="1687" b="0" i="0" lang="zh-CN" dirty="0">
                 <a:solidFill>
-                  <a:srgbClr val="3A4046"/>
+                  <a:srgbClr val="2B333A"/>
                 </a:solidFill>
                 <a:latin typeface="Noto Sans CJK SC"/>
                 <a:ea typeface="Noto Sans CJK SC"/>
@@ -5801,7 +5801,7 @@
             <a:r>
               <a:rPr sz="1687" b="0" i="0" lang="zh-CN" dirty="0">
                 <a:solidFill>
-                  <a:srgbClr val="3A4046"/>
+                  <a:srgbClr val="2B333A"/>
                 </a:solidFill>
                 <a:latin typeface="Noto Sans CJK SC"/>
                 <a:ea typeface="Noto Sans CJK SC"/>
@@ -5812,7 +5812,7 @@
             <a:r>
               <a:rPr sz="1687" b="0" i="0" lang="zh-CN" dirty="0">
                 <a:solidFill>
-                  <a:srgbClr val="3A4046"/>
+                  <a:srgbClr val="2B333A"/>
                 </a:solidFill>
                 <a:latin typeface="DejaVu Sans"/>
                 <a:ea typeface="DejaVu Sans"/>
@@ -5823,7 +5823,7 @@
             <a:r>
               <a:rPr sz="1687" b="0" i="0" lang="zh-CN" dirty="0">
                 <a:solidFill>
-                  <a:srgbClr val="3A4046"/>
+                  <a:srgbClr val="2B333A"/>
                 </a:solidFill>
                 <a:latin typeface="Noto Sans CJK SC"/>
                 <a:ea typeface="Noto Sans CJK SC"/>
@@ -5848,9 +5848,9 @@
           <a:prstGeom prst="line">
             <a:avLst/>
           </a:prstGeom>
-          <a:ln w="23812">
+          <a:ln w="31749">
             <a:solidFill>
-              <a:srgbClr val="1F6F78"/>
+              <a:srgbClr val="1B717D"/>
             </a:solidFill>
           </a:ln>
           <a:effectLst/>
@@ -5878,8 +5878,8 @@
         </p:nvSpPr>
         <p:spPr>
           <a:xfrm>
-            <a:off x="7905750" y="5174313"/>
-            <a:ext cx="309562" cy="278749"/>
+            <a:off x="7903099" y="5171360"/>
+            <a:ext cx="312214" cy="281702"/>
           </a:xfrm>
           <a:custGeom>
             <a:avLst/>
@@ -5888,34 +5888,34 @@
             <a:cxnLst/>
             <a:rect l="l" t="t" r="r" b="b"/>
             <a:pathLst>
-              <a:path w="39000" h="35118">
+              <a:path w="39334" h="35490">
                 <a:moveTo>
-                  <a:pt x="2000" y="0"/>
+                  <a:pt x="2668" y="0"/>
                 </a:moveTo>
                 <a:lnTo>
-                  <a:pt x="29567" y="24665"/>
+                  <a:pt x="28744" y="23331"/>
                 </a:lnTo>
                 <a:lnTo>
-                  <a:pt x="32567" y="21311"/>
+                  <a:pt x="32078" y="19605"/>
                 </a:lnTo>
                 <a:lnTo>
-                  <a:pt x="39000" y="35118"/>
+                  <a:pt x="39334" y="35490"/>
                 </a:lnTo>
                 <a:lnTo>
-                  <a:pt x="24566" y="30254"/>
+                  <a:pt x="22743" y="30038"/>
                 </a:lnTo>
                 <a:lnTo>
-                  <a:pt x="27566" y="26901"/>
+                  <a:pt x="26077" y="26312"/>
                 </a:lnTo>
                 <a:lnTo>
-                  <a:pt x="0" y="2236"/>
+                  <a:pt x="0" y="2980"/>
                 </a:lnTo>
                 <a:close/>
               </a:path>
             </a:pathLst>
           </a:custGeom>
           <a:solidFill>
-            <a:srgbClr val="1F6F78"/>
+            <a:srgbClr val="1B717D"/>
           </a:solidFill>
           <a:ln>
             <a:noFill/>
@@ -5961,11 +5961,11 @@
             </a:avLst>
           </a:prstGeom>
           <a:solidFill>
-            <a:srgbClr val="FFFFFF"/>
+            <a:srgbClr val="E9EDED"/>
           </a:solidFill>
-          <a:ln w="15874">
+          <a:ln w="19843">
             <a:solidFill>
-              <a:srgbClr val="1F6F78"/>
+              <a:srgbClr val="1B717D"/>
             </a:solidFill>
           </a:ln>
           <a:effectLst/>
@@ -6027,7 +6027,7 @@
               </a:spcAft>
               <a:defRPr sz="1499" b="1" i="0" lang="zh-CN" dirty="0">
                 <a:solidFill>
-                  <a:srgbClr val="1F6F78"/>
+                  <a:srgbClr val="1B717D"/>
                 </a:solidFill>
                 <a:latin typeface="Noto Sans CJK SC"/>
                 <a:ea typeface="Noto Sans CJK SC"/>
@@ -6037,7 +6037,7 @@
             <a:r>
               <a:rPr sz="1499" b="1" i="0" lang="zh-CN" dirty="0">
                 <a:solidFill>
-                  <a:srgbClr val="1F6F78"/>
+                  <a:srgbClr val="1B717D"/>
                 </a:solidFill>
                 <a:latin typeface="Noto Sans CJK SC"/>
                 <a:ea typeface="Noto Sans CJK SC"/>
@@ -6067,12 +6067,12 @@
           <a:solidFill>
             <a:srgbClr val="FFFFFF"/>
           </a:solidFill>
-          <a:ln w="19843">
+          <a:ln w="27781">
             <a:solidFill>
-              <a:srgbClr val="B8862B"/>
+              <a:srgbClr val="BD8024"/>
             </a:solidFill>
             <a:custDash>
-              <a:ds d="640000" sp="400000"/>
+              <a:ds d="457143" sp="285714"/>
             </a:custDash>
           </a:ln>
           <a:effectLst/>
@@ -6134,7 +6134,7 @@
               </a:spcAft>
               <a:defRPr sz="1749" b="1" i="0" lang="zh-CN" dirty="0">
                 <a:solidFill>
-                  <a:srgbClr val="1F2326"/>
+                  <a:srgbClr val="10171F"/>
                 </a:solidFill>
                 <a:latin typeface="DejaVu Sans"/>
                 <a:ea typeface="DejaVu Sans"/>
@@ -6144,7 +6144,7 @@
             <a:r>
               <a:rPr sz="1749" b="1" i="0" lang="zh-CN" dirty="0">
                 <a:solidFill>
-                  <a:srgbClr val="1F2326"/>
+                  <a:srgbClr val="10171F"/>
                 </a:solidFill>
                 <a:latin typeface="DejaVu Sans"/>
                 <a:ea typeface="DejaVu Sans"/>
@@ -6190,7 +6190,7 @@
               </a:spcAft>
               <a:defRPr sz="1687" b="0" i="0" lang="zh-CN" dirty="0">
                 <a:solidFill>
-                  <a:srgbClr val="3A4046"/>
+                  <a:srgbClr val="2B333A"/>
                 </a:solidFill>
                 <a:latin typeface="Noto Sans CJK SC"/>
                 <a:ea typeface="Noto Sans CJK SC"/>
@@ -6200,7 +6200,7 @@
             <a:r>
               <a:rPr sz="1687" b="0" i="0" lang="zh-CN" dirty="0">
                 <a:solidFill>
-                  <a:srgbClr val="3A4046"/>
+                  <a:srgbClr val="2B333A"/>
                 </a:solidFill>
                 <a:latin typeface="Noto Sans CJK SC"/>
                 <a:ea typeface="Noto Sans CJK SC"/>
@@ -6225,12 +6225,12 @@
           <a:prstGeom prst="line">
             <a:avLst/>
           </a:prstGeom>
-          <a:ln w="23812">
+          <a:ln w="27781">
             <a:solidFill>
-              <a:srgbClr val="B8862B"/>
+              <a:srgbClr val="BD8024"/>
             </a:solidFill>
             <a:custDash>
-              <a:ds d="466667" sp="300000"/>
+              <a:ds d="400000" sp="257143"/>
             </a:custDash>
           </a:ln>
           <a:effectLst/>
@@ -6267,11 +6267,11 @@
             </a:avLst>
           </a:prstGeom>
           <a:solidFill>
-            <a:srgbClr val="FFFFFF"/>
+            <a:srgbClr val="E9EDED"/>
           </a:solidFill>
-          <a:ln w="15874">
+          <a:ln w="19843">
             <a:solidFill>
-              <a:srgbClr val="B8862B"/>
+              <a:srgbClr val="BD8024"/>
             </a:solidFill>
           </a:ln>
           <a:effectLst/>
@@ -6333,7 +6333,7 @@
               </a:spcAft>
               <a:defRPr sz="1499" b="1" i="0" lang="zh-CN" dirty="0">
                 <a:solidFill>
-                  <a:srgbClr val="7A5A1C"/>
+                  <a:srgbClr val="8A5A10"/>
                 </a:solidFill>
                 <a:latin typeface="Noto Sans CJK SC"/>
                 <a:ea typeface="Noto Sans CJK SC"/>
@@ -6343,7 +6343,7 @@
             <a:r>
               <a:rPr sz="1499" b="1" i="0" lang="zh-CN" dirty="0">
                 <a:solidFill>
-                  <a:srgbClr val="7A5A1C"/>
+                  <a:srgbClr val="8A5A10"/>
                 </a:solidFill>
                 <a:latin typeface="Noto Sans CJK SC"/>
                 <a:ea typeface="Noto Sans CJK SC"/>
@@ -6368,12 +6368,12 @@
           <a:prstGeom prst="line">
             <a:avLst/>
           </a:prstGeom>
-          <a:ln w="23812">
+          <a:ln w="27781">
             <a:solidFill>
-              <a:srgbClr val="B8862B"/>
+              <a:srgbClr val="BD8024"/>
             </a:solidFill>
             <a:custDash>
-              <a:ds d="466667" sp="300000"/>
+              <a:ds d="400000" sp="257143"/>
             </a:custDash>
             <a:tailEnd type="triangle"/>
           </a:ln>

</xml_diff>

<commit_message>
dashboard: 2026-09-13 17:02 刷新
</commit_message>
<xml_diff>
--- a/media/figstudio/bzso_taxonomy/taxonomy_phase_control_editable.pptx
+++ b/media/figstudio/bzso_taxonomy/taxonomy_phase_control_editable.pptx
@@ -3531,11 +3531,11 @@
             <a:avLst/>
           </a:prstGeom>
           <a:solidFill>
-            <a:srgbClr val="FFFFFF"/>
+            <a:srgbClr val="1B717D"/>
           </a:solidFill>
           <a:ln w="31749">
             <a:solidFill>
-              <a:srgbClr val="38525E"/>
+              <a:srgbClr val="145159"/>
             </a:solidFill>
           </a:ln>
           <a:effectLst/>
@@ -3597,7 +3597,7 @@
               </a:spcAft>
               <a:defRPr sz="1999" b="1" i="0" lang="zh-CN" dirty="0">
                 <a:solidFill>
-                  <a:srgbClr val="10171F"/>
+                  <a:srgbClr val="FFFFFF"/>
                 </a:solidFill>
                 <a:latin typeface="DejaVu Sans"/>
                 <a:ea typeface="DejaVu Sans"/>
@@ -3607,7 +3607,7 @@
             <a:r>
               <a:rPr sz="1999" b="1" i="0" lang="zh-CN" dirty="0">
                 <a:solidFill>
-                  <a:srgbClr val="10171F"/>
+                  <a:srgbClr val="FFFFFF"/>
                 </a:solidFill>
                 <a:latin typeface="DejaVu Sans"/>
                 <a:ea typeface="DejaVu Sans"/>
@@ -3629,7 +3629,7 @@
               </a:spcAft>
               <a:defRPr sz="1999" b="1" i="0" lang="zh-CN" dirty="0">
                 <a:solidFill>
-                  <a:srgbClr val="10171F"/>
+                  <a:srgbClr val="FFFFFF"/>
                 </a:solidFill>
                 <a:latin typeface="Noto Sans CJK SC"/>
                 <a:ea typeface="Noto Sans CJK SC"/>
@@ -3639,7 +3639,7 @@
             <a:r>
               <a:rPr sz="1999" b="1" i="0" lang="zh-CN" dirty="0">
                 <a:solidFill>
-                  <a:srgbClr val="10171F"/>
+                  <a:srgbClr val="FFFFFF"/>
                 </a:solidFill>
                 <a:latin typeface="Noto Sans CJK SC"/>
                 <a:ea typeface="Noto Sans CJK SC"/>
@@ -3667,7 +3667,7 @@
             </a:avLst>
           </a:prstGeom>
           <a:solidFill>
-            <a:srgbClr val="FFFFFF"/>
+            <a:srgbClr val="F2F5F7"/>
           </a:solidFill>
           <a:ln w="27781">
             <a:solidFill>
@@ -3959,11 +3959,11 @@
             </a:avLst>
           </a:prstGeom>
           <a:solidFill>
-            <a:srgbClr val="E9EDED"/>
+            <a:srgbClr val="1B717D"/>
           </a:solidFill>
           <a:ln w="19843">
             <a:solidFill>
-              <a:srgbClr val="1B717D"/>
+              <a:srgbClr val="145159"/>
             </a:solidFill>
           </a:ln>
           <a:effectLst/>
@@ -4025,7 +4025,7 @@
               </a:spcAft>
               <a:defRPr sz="1499" b="1" i="0" lang="zh-CN" dirty="0">
                 <a:solidFill>
-                  <a:srgbClr val="1B717D"/>
+                  <a:srgbClr val="FFFFFF"/>
                 </a:solidFill>
                 <a:latin typeface="Noto Sans CJK SC"/>
                 <a:ea typeface="Noto Sans CJK SC"/>
@@ -4035,7 +4035,7 @@
             <a:r>
               <a:rPr sz="1499" b="1" i="0" lang="zh-CN" dirty="0">
                 <a:solidFill>
-                  <a:srgbClr val="1B717D"/>
+                  <a:srgbClr val="FFFFFF"/>
                 </a:solidFill>
                 <a:latin typeface="Noto Sans CJK SC"/>
                 <a:ea typeface="Noto Sans CJK SC"/>
@@ -4063,7 +4063,7 @@
             </a:avLst>
           </a:prstGeom>
           <a:solidFill>
-            <a:srgbClr val="FFFFFF"/>
+            <a:srgbClr val="F2F5F7"/>
           </a:solidFill>
           <a:ln w="27781">
             <a:solidFill>
@@ -4377,11 +4377,11 @@
             </a:avLst>
           </a:prstGeom>
           <a:solidFill>
-            <a:srgbClr val="E9EDED"/>
+            <a:srgbClr val="1B717D"/>
           </a:solidFill>
           <a:ln w="19843">
             <a:solidFill>
-              <a:srgbClr val="1B717D"/>
+              <a:srgbClr val="145159"/>
             </a:solidFill>
           </a:ln>
           <a:effectLst/>
@@ -4443,7 +4443,7 @@
               </a:spcAft>
               <a:defRPr sz="1499" b="1" i="0" lang="zh-CN" dirty="0">
                 <a:solidFill>
-                  <a:srgbClr val="1B717D"/>
+                  <a:srgbClr val="FFFFFF"/>
                 </a:solidFill>
                 <a:latin typeface="Noto Sans CJK SC"/>
                 <a:ea typeface="Noto Sans CJK SC"/>
@@ -4453,7 +4453,7 @@
             <a:r>
               <a:rPr sz="1499" b="1" i="0" lang="zh-CN" dirty="0">
                 <a:solidFill>
-                  <a:srgbClr val="1B717D"/>
+                  <a:srgbClr val="FFFFFF"/>
                 </a:solidFill>
                 <a:latin typeface="Noto Sans CJK SC"/>
                 <a:ea typeface="Noto Sans CJK SC"/>
@@ -4481,7 +4481,7 @@
             </a:avLst>
           </a:prstGeom>
           <a:solidFill>
-            <a:srgbClr val="FFFFFF"/>
+            <a:srgbClr val="F2F5F7"/>
           </a:solidFill>
           <a:ln w="27781">
             <a:solidFill>
@@ -4762,11 +4762,11 @@
             </a:avLst>
           </a:prstGeom>
           <a:solidFill>
-            <a:srgbClr val="E9EDED"/>
+            <a:srgbClr val="1B717D"/>
           </a:solidFill>
           <a:ln w="19843">
             <a:solidFill>
-              <a:srgbClr val="1B717D"/>
+              <a:srgbClr val="145159"/>
             </a:solidFill>
           </a:ln>
           <a:effectLst/>
@@ -4828,7 +4828,7 @@
               </a:spcAft>
               <a:defRPr sz="1499" b="1" i="0" lang="zh-CN" dirty="0">
                 <a:solidFill>
-                  <a:srgbClr val="1B717D"/>
+                  <a:srgbClr val="FFFFFF"/>
                 </a:solidFill>
                 <a:latin typeface="Noto Sans CJK SC"/>
                 <a:ea typeface="Noto Sans CJK SC"/>
@@ -4838,7 +4838,7 @@
             <a:r>
               <a:rPr sz="1499" b="1" i="0" lang="zh-CN" dirty="0">
                 <a:solidFill>
-                  <a:srgbClr val="1B717D"/>
+                  <a:srgbClr val="FFFFFF"/>
                 </a:solidFill>
                 <a:latin typeface="Noto Sans CJK SC"/>
                 <a:ea typeface="Noto Sans CJK SC"/>
@@ -4866,7 +4866,7 @@
             </a:avLst>
           </a:prstGeom>
           <a:solidFill>
-            <a:srgbClr val="FFFFFF"/>
+            <a:srgbClr val="F2F5F7"/>
           </a:solidFill>
           <a:ln w="27781">
             <a:solidFill>
@@ -5180,11 +5180,11 @@
             </a:avLst>
           </a:prstGeom>
           <a:solidFill>
-            <a:srgbClr val="E9EDED"/>
+            <a:srgbClr val="1B717D"/>
           </a:solidFill>
           <a:ln w="19843">
             <a:solidFill>
-              <a:srgbClr val="1B717D"/>
+              <a:srgbClr val="145159"/>
             </a:solidFill>
           </a:ln>
           <a:effectLst/>
@@ -5246,7 +5246,7 @@
               </a:spcAft>
               <a:defRPr sz="1499" b="1" i="0" lang="zh-CN" dirty="0">
                 <a:solidFill>
-                  <a:srgbClr val="1B717D"/>
+                  <a:srgbClr val="FFFFFF"/>
                 </a:solidFill>
                 <a:latin typeface="Noto Sans CJK SC"/>
                 <a:ea typeface="Noto Sans CJK SC"/>
@@ -5256,7 +5256,7 @@
             <a:r>
               <a:rPr sz="1499" b="1" i="0" lang="zh-CN" dirty="0">
                 <a:solidFill>
-                  <a:srgbClr val="1B717D"/>
+                  <a:srgbClr val="FFFFFF"/>
                 </a:solidFill>
                 <a:latin typeface="Noto Sans CJK SC"/>
                 <a:ea typeface="Noto Sans CJK SC"/>
@@ -5284,7 +5284,7 @@
             </a:avLst>
           </a:prstGeom>
           <a:solidFill>
-            <a:srgbClr val="FFFFFF"/>
+            <a:srgbClr val="F2F5F7"/>
           </a:solidFill>
           <a:ln w="27781">
             <a:solidFill>
@@ -5565,11 +5565,11 @@
             </a:avLst>
           </a:prstGeom>
           <a:solidFill>
-            <a:srgbClr val="E9EDED"/>
+            <a:srgbClr val="1B717D"/>
           </a:solidFill>
           <a:ln w="19843">
             <a:solidFill>
-              <a:srgbClr val="1B717D"/>
+              <a:srgbClr val="145159"/>
             </a:solidFill>
           </a:ln>
           <a:effectLst/>
@@ -5631,7 +5631,7 @@
               </a:spcAft>
               <a:defRPr sz="1499" b="1" i="0" lang="zh-CN" dirty="0">
                 <a:solidFill>
-                  <a:srgbClr val="1B717D"/>
+                  <a:srgbClr val="FFFFFF"/>
                 </a:solidFill>
                 <a:latin typeface="Noto Sans CJK SC"/>
                 <a:ea typeface="Noto Sans CJK SC"/>
@@ -5641,7 +5641,7 @@
             <a:r>
               <a:rPr sz="1499" b="1" i="0" lang="zh-CN" dirty="0">
                 <a:solidFill>
-                  <a:srgbClr val="1B717D"/>
+                  <a:srgbClr val="FFFFFF"/>
                 </a:solidFill>
                 <a:latin typeface="Noto Sans CJK SC"/>
                 <a:ea typeface="Noto Sans CJK SC"/>
@@ -5669,7 +5669,7 @@
             </a:avLst>
           </a:prstGeom>
           <a:solidFill>
-            <a:srgbClr val="FFFFFF"/>
+            <a:srgbClr val="F2F5F7"/>
           </a:solidFill>
           <a:ln w="27781">
             <a:solidFill>
@@ -5961,11 +5961,11 @@
             </a:avLst>
           </a:prstGeom>
           <a:solidFill>
-            <a:srgbClr val="E9EDED"/>
+            <a:srgbClr val="1B717D"/>
           </a:solidFill>
           <a:ln w="19843">
             <a:solidFill>
-              <a:srgbClr val="1B717D"/>
+              <a:srgbClr val="145159"/>
             </a:solidFill>
           </a:ln>
           <a:effectLst/>
@@ -6027,7 +6027,7 @@
               </a:spcAft>
               <a:defRPr sz="1499" b="1" i="0" lang="zh-CN" dirty="0">
                 <a:solidFill>
-                  <a:srgbClr val="1B717D"/>
+                  <a:srgbClr val="FFFFFF"/>
                 </a:solidFill>
                 <a:latin typeface="Noto Sans CJK SC"/>
                 <a:ea typeface="Noto Sans CJK SC"/>
@@ -6037,7 +6037,7 @@
             <a:r>
               <a:rPr sz="1499" b="1" i="0" lang="zh-CN" dirty="0">
                 <a:solidFill>
-                  <a:srgbClr val="1B717D"/>
+                  <a:srgbClr val="FFFFFF"/>
                 </a:solidFill>
                 <a:latin typeface="Noto Sans CJK SC"/>
                 <a:ea typeface="Noto Sans CJK SC"/>
@@ -6065,11 +6065,11 @@
             </a:avLst>
           </a:prstGeom>
           <a:solidFill>
-            <a:srgbClr val="FFFFFF"/>
+            <a:srgbClr val="FBF1DC"/>
           </a:solidFill>
           <a:ln w="27781">
             <a:solidFill>
-              <a:srgbClr val="BD8024"/>
+              <a:srgbClr val="B8781E"/>
             </a:solidFill>
             <a:custDash>
               <a:ds d="457143" sp="285714"/>
@@ -6227,7 +6227,7 @@
           </a:prstGeom>
           <a:ln w="27781">
             <a:solidFill>
-              <a:srgbClr val="BD8024"/>
+              <a:srgbClr val="B8781E"/>
             </a:solidFill>
             <a:custDash>
               <a:ds d="400000" sp="257143"/>
@@ -6267,11 +6267,11 @@
             </a:avLst>
           </a:prstGeom>
           <a:solidFill>
-            <a:srgbClr val="E9EDED"/>
+            <a:srgbClr val="B8781E"/>
           </a:solidFill>
           <a:ln w="19843">
             <a:solidFill>
-              <a:srgbClr val="BD8024"/>
+              <a:srgbClr val="8A5A10"/>
             </a:solidFill>
           </a:ln>
           <a:effectLst/>
@@ -6333,7 +6333,7 @@
               </a:spcAft>
               <a:defRPr sz="1499" b="1" i="0" lang="zh-CN" dirty="0">
                 <a:solidFill>
-                  <a:srgbClr val="8A5A10"/>
+                  <a:srgbClr val="FFFFFF"/>
                 </a:solidFill>
                 <a:latin typeface="Noto Sans CJK SC"/>
                 <a:ea typeface="Noto Sans CJK SC"/>
@@ -6343,7 +6343,7 @@
             <a:r>
               <a:rPr sz="1499" b="1" i="0" lang="zh-CN" dirty="0">
                 <a:solidFill>
-                  <a:srgbClr val="8A5A10"/>
+                  <a:srgbClr val="FFFFFF"/>
                 </a:solidFill>
                 <a:latin typeface="Noto Sans CJK SC"/>
                 <a:ea typeface="Noto Sans CJK SC"/>
@@ -6370,7 +6370,7 @@
           </a:prstGeom>
           <a:ln w="27781">
             <a:solidFill>
-              <a:srgbClr val="BD8024"/>
+              <a:srgbClr val="B8781E"/>
             </a:solidFill>
             <a:custDash>
               <a:ds d="400000" sp="257143"/>

</xml_diff>